<commit_message>
Harden presentation readiness and deployment safeguards.
Unify the presenter documentation and UI, make demo failures explicit and recoverable, repair migration and country-pack packaging, and fail closed for national deployment templates.

Co-authored-by: Cursor <cursoragent@cursor.com>
</commit_message>
<xml_diff>
--- a/docs/presentations/MboaShield_SIN2026.pptx
+++ b/docs/presentations/MboaShield_SIN2026.pptx
@@ -3089,6 +3089,14 @@
 <file path=ppt/slides/slide1.xml><?xml version="1.0" encoding="utf-8"?>
 <p:sld xmlns:a="http://schemas.openxmlformats.org/drawingml/2006/main" xmlns:p="http://schemas.openxmlformats.org/presentationml/2006/main" xmlns:r="http://schemas.openxmlformats.org/officeDocument/2006/relationships">
   <p:cSld>
+    <p:bg>
+      <p:bgPr>
+        <a:solidFill>
+          <a:srgbClr val="071F1A"/>
+        </a:solidFill>
+        <a:effectLst/>
+      </p:bgPr>
+    </p:bg>
     <p:spTree>
       <p:nvGrpSpPr>
         <p:cNvPr id="1" name=""/>
@@ -3111,6 +3119,14 @@
           <a:bodyPr/>
           <a:lstStyle/>
           <a:p>
+            <a:pPr>
+              <a:defRPr sz="4800" b="1">
+                <a:solidFill>
+                  <a:srgbClr val="F8FAFC"/>
+                </a:solidFill>
+                <a:latin typeface="Aptos Display"/>
+              </a:defRPr>
+            </a:pPr>
             <a:r>
               <a:t>MboaShield</a:t>
             </a:r>
@@ -3132,23 +3148,146 @@
           <a:bodyPr/>
           <a:lstStyle/>
           <a:p>
+            <a:pPr>
+              <a:spcAft>
+                <a:spcPts val="600"/>
+              </a:spcAft>
+              <a:defRPr sz="2000">
+                <a:solidFill>
+                  <a:srgbClr val="CBD5E1"/>
+                </a:solidFill>
+                <a:latin typeface="Aptos"/>
+              </a:defRPr>
+            </a:pPr>
             <a:r>
               <a:t>Sovereign AI shield against deepfakes, disinformation and digital identity theft</a:t>
             </a:r>
           </a:p>
           <a:p>
+            <a:pPr>
+              <a:spcAft>
+                <a:spcPts val="600"/>
+              </a:spcAft>
+              <a:defRPr sz="2000">
+                <a:solidFill>
+                  <a:srgbClr val="CBD5E1"/>
+                </a:solidFill>
+                <a:latin typeface="Aptos"/>
+              </a:defRPr>
+            </a:pPr>
             <a:r>
               <a:t>Made in Cameroon - SIN 2026 National Best ICT Project</a:t>
             </a:r>
           </a:p>
           <a:p>
+            <a:pPr>
+              <a:spcAft>
+                <a:spcPts val="600"/>
+              </a:spcAft>
+              <a:defRPr sz="2000">
+                <a:solidFill>
+                  <a:srgbClr val="CBD5E1"/>
+                </a:solidFill>
+                <a:latin typeface="Aptos"/>
+              </a:defRPr>
+            </a:pPr>
             <a:r>
               <a:t>Solo founder: Justene Nkwagoh Tamah</a:t>
             </a:r>
           </a:p>
           <a:p>
+            <a:pPr>
+              <a:spcAft>
+                <a:spcPts val="600"/>
+              </a:spcAft>
+              <a:defRPr sz="2000">
+                <a:solidFill>
+                  <a:srgbClr val="CBD5E1"/>
+                </a:solidFill>
+                <a:latin typeface="Aptos"/>
+              </a:defRPr>
+            </a:pPr>
             <a:r>
               <a:t>Theme: Protect cyberspace from AI excesses and digital patriotism</a:t>
+            </a:r>
+          </a:p>
+        </p:txBody>
+      </p:sp>
+      <p:sp>
+        <p:nvSpPr>
+          <p:cNvPr id="4" name="Rectangle 3"/>
+          <p:cNvSpPr/>
+          <p:nvPr/>
+        </p:nvSpPr>
+        <p:spPr>
+          <a:xfrm>
+            <a:off x="0" y="0"/>
+            <a:ext cx="146304" cy="6858000"/>
+          </a:xfrm>
+          <a:prstGeom prst="rect">
+            <a:avLst/>
+          </a:prstGeom>
+          <a:solidFill>
+            <a:srgbClr val="22C55E"/>
+          </a:solidFill>
+          <a:ln>
+            <a:noFill/>
+          </a:ln>
+        </p:spPr>
+        <p:style>
+          <a:lnRef idx="1">
+            <a:schemeClr val="accent1"/>
+          </a:lnRef>
+          <a:fillRef idx="3">
+            <a:schemeClr val="accent1"/>
+          </a:fillRef>
+          <a:effectRef idx="2">
+            <a:schemeClr val="accent1"/>
+          </a:effectRef>
+          <a:fontRef idx="minor">
+            <a:schemeClr val="lt1"/>
+          </a:fontRef>
+        </p:style>
+        <p:txBody>
+          <a:bodyPr rtlCol="0" anchor="ctr"/>
+          <a:lstStyle/>
+          <a:p>
+            <a:pPr algn="ctr"/>
+          </a:p>
+        </p:txBody>
+      </p:sp>
+      <p:sp>
+        <p:nvSpPr>
+          <p:cNvPr id="5" name="TextBox 4"/>
+          <p:cNvSpPr txBox="1"/>
+          <p:nvPr/>
+        </p:nvSpPr>
+        <p:spPr>
+          <a:xfrm>
+            <a:off x="658368" y="6473952"/>
+            <a:ext cx="10881360" cy="219456"/>
+          </a:xfrm>
+          <a:prstGeom prst="rect">
+            <a:avLst/>
+          </a:prstGeom>
+          <a:noFill/>
+        </p:spPr>
+        <p:txBody>
+          <a:bodyPr wrap="none">
+            <a:spAutoFit/>
+          </a:bodyPr>
+          <a:lstStyle/>
+          <a:p>
+            <a:pPr algn="l">
+              <a:defRPr sz="800">
+                <a:solidFill>
+                  <a:srgbClr val="CBD5E1"/>
+                </a:solidFill>
+                <a:latin typeface="Aptos"/>
+              </a:defRPr>
+            </a:pPr>
+            <a:r>
+              <a:t>MBOASHIELD · SOVEREIGN DIGITAL TRUST INFRASTRUCTURE                                      01</a:t>
             </a:r>
           </a:p>
         </p:txBody>
@@ -3164,6 +3303,14 @@
 <file path=ppt/slides/slide2.xml><?xml version="1.0" encoding="utf-8"?>
 <p:sld xmlns:a="http://schemas.openxmlformats.org/drawingml/2006/main" xmlns:p="http://schemas.openxmlformats.org/presentationml/2006/main" xmlns:r="http://schemas.openxmlformats.org/officeDocument/2006/relationships">
   <p:cSld>
+    <p:bg>
+      <p:bgPr>
+        <a:solidFill>
+          <a:srgbClr val="071F1A"/>
+        </a:solidFill>
+        <a:effectLst/>
+      </p:bgPr>
+    </p:bg>
     <p:spTree>
       <p:nvGrpSpPr>
         <p:cNvPr id="1" name=""/>
@@ -3187,6 +3334,12 @@
           <a:lstStyle/>
           <a:p>
             <a:r>
+              <a:rPr sz="3000" b="1">
+                <a:solidFill>
+                  <a:srgbClr val="F8FAFC"/>
+                </a:solidFill>
+                <a:latin typeface="Aptos Display"/>
+              </a:rPr>
               <a:t>The problem (Cameroon, today)</a:t>
             </a:r>
           </a:p>
@@ -3204,11 +3357,19 @@
         </p:nvSpPr>
         <p:spPr/>
         <p:txBody>
-          <a:bodyPr/>
+          <a:bodyPr lIns="109728"/>
           <a:lstStyle/>
           <a:p>
             <a:pPr>
-              <a:defRPr sz="2000"/>
+              <a:spcAft>
+                <a:spcPts val="1300"/>
+              </a:spcAft>
+              <a:defRPr sz="2100">
+                <a:solidFill>
+                  <a:srgbClr val="F8FAFC"/>
+                </a:solidFill>
+                <a:latin typeface="Aptos"/>
+              </a:defRPr>
             </a:pPr>
             <a:r>
               <a:t>Fake minister announcements and curfew hoaxes on WhatsApp</a:t>
@@ -3216,7 +3377,15 @@
           </a:p>
           <a:p>
             <a:pPr>
-              <a:defRPr sz="2000"/>
+              <a:spcAft>
+                <a:spcPts val="1300"/>
+              </a:spcAft>
+              <a:defRPr sz="2100">
+                <a:solidFill>
+                  <a:srgbClr val="F8FAFC"/>
+                </a:solidFill>
+                <a:latin typeface="Aptos"/>
+              </a:defRPr>
             </a:pPr>
             <a:r>
               <a:t>Voice clones demanding MoMo transfers</a:t>
@@ -3224,7 +3393,15 @@
           </a:p>
           <a:p>
             <a:pPr>
-              <a:defRPr sz="2000"/>
+              <a:spcAft>
+                <a:spcPts val="1300"/>
+              </a:spcAft>
+              <a:defRPr sz="2100">
+                <a:solidFill>
+                  <a:srgbClr val="F8FAFC"/>
+                </a:solidFill>
+                <a:latin typeface="Aptos"/>
+              </a:defRPr>
             </a:pPr>
             <a:r>
               <a:t>Deepfake images targeting institutions and public figures</a:t>
@@ -3232,10 +3409,97 @@
           </a:p>
           <a:p>
             <a:pPr>
-              <a:defRPr sz="2000"/>
+              <a:spcAft>
+                <a:spcPts val="1300"/>
+              </a:spcAft>
+              <a:defRPr sz="2100">
+                <a:solidFill>
+                  <a:srgbClr val="F8FAFC"/>
+                </a:solidFill>
+                <a:latin typeface="Aptos"/>
+              </a:defRPr>
             </a:pPr>
             <a:r>
               <a:t>Youth forward before verifying - fraud, panic, eroded trust</a:t>
+            </a:r>
+          </a:p>
+        </p:txBody>
+      </p:sp>
+      <p:sp>
+        <p:nvSpPr>
+          <p:cNvPr id="4" name="Rectangle 3"/>
+          <p:cNvSpPr/>
+          <p:nvPr/>
+        </p:nvSpPr>
+        <p:spPr>
+          <a:xfrm>
+            <a:off x="0" y="0"/>
+            <a:ext cx="146304" cy="6858000"/>
+          </a:xfrm>
+          <a:prstGeom prst="rect">
+            <a:avLst/>
+          </a:prstGeom>
+          <a:solidFill>
+            <a:srgbClr val="22C55E"/>
+          </a:solidFill>
+          <a:ln>
+            <a:noFill/>
+          </a:ln>
+        </p:spPr>
+        <p:style>
+          <a:lnRef idx="1">
+            <a:schemeClr val="accent1"/>
+          </a:lnRef>
+          <a:fillRef idx="3">
+            <a:schemeClr val="accent1"/>
+          </a:fillRef>
+          <a:effectRef idx="2">
+            <a:schemeClr val="accent1"/>
+          </a:effectRef>
+          <a:fontRef idx="minor">
+            <a:schemeClr val="lt1"/>
+          </a:fontRef>
+        </p:style>
+        <p:txBody>
+          <a:bodyPr rtlCol="0" anchor="ctr"/>
+          <a:lstStyle/>
+          <a:p>
+            <a:pPr algn="ctr"/>
+          </a:p>
+        </p:txBody>
+      </p:sp>
+      <p:sp>
+        <p:nvSpPr>
+          <p:cNvPr id="5" name="TextBox 4"/>
+          <p:cNvSpPr txBox="1"/>
+          <p:nvPr/>
+        </p:nvSpPr>
+        <p:spPr>
+          <a:xfrm>
+            <a:off x="658368" y="6473952"/>
+            <a:ext cx="10881360" cy="219456"/>
+          </a:xfrm>
+          <a:prstGeom prst="rect">
+            <a:avLst/>
+          </a:prstGeom>
+          <a:noFill/>
+        </p:spPr>
+        <p:txBody>
+          <a:bodyPr wrap="none">
+            <a:spAutoFit/>
+          </a:bodyPr>
+          <a:lstStyle/>
+          <a:p>
+            <a:pPr algn="l">
+              <a:defRPr sz="800">
+                <a:solidFill>
+                  <a:srgbClr val="CBD5E1"/>
+                </a:solidFill>
+                <a:latin typeface="Aptos"/>
+              </a:defRPr>
+            </a:pPr>
+            <a:r>
+              <a:t>MBOASHIELD · SOVEREIGN DIGITAL TRUST INFRASTRUCTURE                                      02</a:t>
             </a:r>
           </a:p>
         </p:txBody>
@@ -3251,6 +3515,14 @@
 <file path=ppt/slides/slide3.xml><?xml version="1.0" encoding="utf-8"?>
 <p:sld xmlns:a="http://schemas.openxmlformats.org/drawingml/2006/main" xmlns:p="http://schemas.openxmlformats.org/presentationml/2006/main" xmlns:r="http://schemas.openxmlformats.org/officeDocument/2006/relationships">
   <p:cSld>
+    <p:bg>
+      <p:bgPr>
+        <a:solidFill>
+          <a:srgbClr val="071F1A"/>
+        </a:solidFill>
+        <a:effectLst/>
+      </p:bgPr>
+    </p:bg>
     <p:spTree>
       <p:nvGrpSpPr>
         <p:cNvPr id="1" name=""/>
@@ -3274,6 +3546,12 @@
           <a:lstStyle/>
           <a:p>
             <a:r>
+              <a:rPr sz="3000" b="1">
+                <a:solidFill>
+                  <a:srgbClr val="F8FAFC"/>
+                </a:solidFill>
+                <a:latin typeface="Aptos Display"/>
+              </a:rPr>
               <a:t>The solution</a:t>
             </a:r>
           </a:p>
@@ -3291,11 +3569,19 @@
         </p:nvSpPr>
         <p:spPr/>
         <p:txBody>
-          <a:bodyPr/>
+          <a:bodyPr lIns="109728"/>
           <a:lstStyle/>
           <a:p>
             <a:pPr>
-              <a:defRPr sz="2000"/>
+              <a:spcAft>
+                <a:spcPts val="1300"/>
+              </a:spcAft>
+              <a:defRPr sz="2100">
+                <a:solidFill>
+                  <a:srgbClr val="F8FAFC"/>
+                </a:solidFill>
+                <a:latin typeface="Aptos"/>
+              </a:defRPr>
             </a:pPr>
             <a:r>
               <a:t>Detect synthetic media and scam patterns</a:t>
@@ -3303,7 +3589,15 @@
           </a:p>
           <a:p>
             <a:pPr>
-              <a:defRPr sz="2000"/>
+              <a:spcAft>
+                <a:spcPts val="1300"/>
+              </a:spcAft>
+              <a:defRPr sz="2100">
+                <a:solidFill>
+                  <a:srgbClr val="F8FAFC"/>
+                </a:solidFill>
+                <a:latin typeface="Aptos"/>
+              </a:defRPr>
             </a:pPr>
             <a:r>
               <a:t>Verify rumours and flag fake official accounts</a:t>
@@ -3311,7 +3605,15 @@
           </a:p>
           <a:p>
             <a:pPr>
-              <a:defRPr sz="2000"/>
+              <a:spcAft>
+                <a:spcPts val="1300"/>
+              </a:spcAft>
+              <a:defRPr sz="2100">
+                <a:solidFill>
+                  <a:srgbClr val="F8FAFC"/>
+                </a:solidFill>
+                <a:latin typeface="Aptos"/>
+              </a:defRPr>
             </a:pPr>
             <a:r>
               <a:t>Train Mboa Ambassadors in digital patriotism</a:t>
@@ -3319,10 +3621,97 @@
           </a:p>
           <a:p>
             <a:pPr>
-              <a:defRPr sz="2000"/>
+              <a:spcAft>
+                <a:spcPts val="1300"/>
+              </a:spcAft>
+              <a:defRPr sz="2100">
+                <a:solidFill>
+                  <a:srgbClr val="F8FAFC"/>
+                </a:solidFill>
+                <a:latin typeface="Aptos"/>
+              </a:defRPr>
             </a:pPr>
             <a:r>
-              <a:t>WhatsApp-first narrative - FR/EN - privacy by design - sovereign stack</a:t>
+              <a:t>WhatsApp-style demo narrative - partial FR/EN UI - privacy-aware sovereign stack</a:t>
+            </a:r>
+          </a:p>
+        </p:txBody>
+      </p:sp>
+      <p:sp>
+        <p:nvSpPr>
+          <p:cNvPr id="4" name="Rectangle 3"/>
+          <p:cNvSpPr/>
+          <p:nvPr/>
+        </p:nvSpPr>
+        <p:spPr>
+          <a:xfrm>
+            <a:off x="0" y="0"/>
+            <a:ext cx="146304" cy="6858000"/>
+          </a:xfrm>
+          <a:prstGeom prst="rect">
+            <a:avLst/>
+          </a:prstGeom>
+          <a:solidFill>
+            <a:srgbClr val="22C55E"/>
+          </a:solidFill>
+          <a:ln>
+            <a:noFill/>
+          </a:ln>
+        </p:spPr>
+        <p:style>
+          <a:lnRef idx="1">
+            <a:schemeClr val="accent1"/>
+          </a:lnRef>
+          <a:fillRef idx="3">
+            <a:schemeClr val="accent1"/>
+          </a:fillRef>
+          <a:effectRef idx="2">
+            <a:schemeClr val="accent1"/>
+          </a:effectRef>
+          <a:fontRef idx="minor">
+            <a:schemeClr val="lt1"/>
+          </a:fontRef>
+        </p:style>
+        <p:txBody>
+          <a:bodyPr rtlCol="0" anchor="ctr"/>
+          <a:lstStyle/>
+          <a:p>
+            <a:pPr algn="ctr"/>
+          </a:p>
+        </p:txBody>
+      </p:sp>
+      <p:sp>
+        <p:nvSpPr>
+          <p:cNvPr id="5" name="TextBox 4"/>
+          <p:cNvSpPr txBox="1"/>
+          <p:nvPr/>
+        </p:nvSpPr>
+        <p:spPr>
+          <a:xfrm>
+            <a:off x="658368" y="6473952"/>
+            <a:ext cx="10881360" cy="219456"/>
+          </a:xfrm>
+          <a:prstGeom prst="rect">
+            <a:avLst/>
+          </a:prstGeom>
+          <a:noFill/>
+        </p:spPr>
+        <p:txBody>
+          <a:bodyPr wrap="none">
+            <a:spAutoFit/>
+          </a:bodyPr>
+          <a:lstStyle/>
+          <a:p>
+            <a:pPr algn="l">
+              <a:defRPr sz="800">
+                <a:solidFill>
+                  <a:srgbClr val="CBD5E1"/>
+                </a:solidFill>
+                <a:latin typeface="Aptos"/>
+              </a:defRPr>
+            </a:pPr>
+            <a:r>
+              <a:t>MBOASHIELD · SOVEREIGN DIGITAL TRUST INFRASTRUCTURE                                      03</a:t>
             </a:r>
           </a:p>
         </p:txBody>
@@ -3338,6 +3727,14 @@
 <file path=ppt/slides/slide4.xml><?xml version="1.0" encoding="utf-8"?>
 <p:sld xmlns:a="http://schemas.openxmlformats.org/drawingml/2006/main" xmlns:p="http://schemas.openxmlformats.org/presentationml/2006/main" xmlns:r="http://schemas.openxmlformats.org/officeDocument/2006/relationships">
   <p:cSld>
+    <p:bg>
+      <p:bgPr>
+        <a:solidFill>
+          <a:srgbClr val="071F1A"/>
+        </a:solidFill>
+        <a:effectLst/>
+      </p:bgPr>
+    </p:bg>
     <p:spTree>
       <p:nvGrpSpPr>
         <p:cNvPr id="1" name=""/>
@@ -3361,6 +3758,12 @@
           <a:lstStyle/>
           <a:p>
             <a:r>
+              <a:rPr sz="3000" b="1">
+                <a:solidFill>
+                  <a:srgbClr val="F8FAFC"/>
+                </a:solidFill>
+                <a:latin typeface="Aptos Display"/>
+              </a:rPr>
               <a:t>Live demo (90 seconds)</a:t>
             </a:r>
           </a:p>
@@ -3378,11 +3781,19 @@
         </p:nvSpPr>
         <p:spPr/>
         <p:txBody>
-          <a:bodyPr/>
+          <a:bodyPr lIns="109728"/>
           <a:lstStyle/>
           <a:p>
             <a:pPr>
-              <a:defRPr sz="2000"/>
+              <a:spcAft>
+                <a:spcPts val="1300"/>
+              </a:spcAft>
+              <a:defRPr sz="2100">
+                <a:solidFill>
+                  <a:srgbClr val="F8FAFC"/>
+                </a:solidFill>
+                <a:latin typeface="Aptos"/>
+              </a:defRPr>
             </a:pPr>
             <a:r>
               <a:t>1. Viral rumour - risk score and source check</a:t>
@@ -3390,7 +3801,15 @@
           </a:p>
           <a:p>
             <a:pPr>
-              <a:defRPr sz="2000"/>
+              <a:spcAft>
+                <a:spcPts val="1300"/>
+              </a:spcAft>
+              <a:defRPr sz="2100">
+                <a:solidFill>
+                  <a:srgbClr val="F8FAFC"/>
+                </a:solidFill>
+                <a:latin typeface="Aptos"/>
+              </a:defRPr>
             </a:pPr>
             <a:r>
               <a:t>2. Fake MINPOSTEL-style account - impersonation</a:t>
@@ -3398,7 +3817,15 @@
           </a:p>
           <a:p>
             <a:pPr>
-              <a:defRPr sz="2000"/>
+              <a:spcAft>
+                <a:spcPts val="1300"/>
+              </a:spcAft>
+              <a:defRPr sz="2100">
+                <a:solidFill>
+                  <a:srgbClr val="F8FAFC"/>
+                </a:solidFill>
+                <a:latin typeface="Aptos"/>
+              </a:defRPr>
             </a:pPr>
             <a:r>
               <a:t>3. Minister voice sample - clone risk</a:t>
@@ -3406,7 +3833,15 @@
           </a:p>
           <a:p>
             <a:pPr>
-              <a:defRPr sz="2000"/>
+              <a:spcAft>
+                <a:spcPts val="1300"/>
+              </a:spcAft>
+              <a:defRPr sz="2100">
+                <a:solidFill>
+                  <a:srgbClr val="F8FAFC"/>
+                </a:solidFill>
+                <a:latin typeface="Aptos"/>
+              </a:defRPr>
             </a:pPr>
             <a:r>
               <a:t>4. Suspicious image - synthetic signals</a:t>
@@ -3414,7 +3849,15 @@
           </a:p>
           <a:p>
             <a:pPr>
-              <a:defRPr sz="2000"/>
+              <a:spcAft>
+                <a:spcPts val="1300"/>
+              </a:spcAft>
+              <a:defRPr sz="2100">
+                <a:solidFill>
+                  <a:srgbClr val="F8FAFC"/>
+                </a:solidFill>
+                <a:latin typeface="Aptos"/>
+              </a:defRPr>
             </a:pPr>
             <a:r>
               <a:t>5. Mboa Ambassador certificate</a:t>
@@ -3422,10 +3865,97 @@
           </a:p>
           <a:p>
             <a:pPr>
-              <a:defRPr sz="2000"/>
+              <a:spcAft>
+                <a:spcPts val="1300"/>
+              </a:spcAft>
+              <a:defRPr sz="2100">
+                <a:solidFill>
+                  <a:srgbClr val="F8FAFC"/>
+                </a:solidFill>
+                <a:latin typeface="Aptos"/>
+              </a:defRPr>
             </a:pPr>
             <a:r>
               <a:t>Demo: mboashield.onrender.com - Run Grand Jury demo</a:t>
+            </a:r>
+          </a:p>
+        </p:txBody>
+      </p:sp>
+      <p:sp>
+        <p:nvSpPr>
+          <p:cNvPr id="4" name="Rectangle 3"/>
+          <p:cNvSpPr/>
+          <p:nvPr/>
+        </p:nvSpPr>
+        <p:spPr>
+          <a:xfrm>
+            <a:off x="0" y="0"/>
+            <a:ext cx="146304" cy="6858000"/>
+          </a:xfrm>
+          <a:prstGeom prst="rect">
+            <a:avLst/>
+          </a:prstGeom>
+          <a:solidFill>
+            <a:srgbClr val="22C55E"/>
+          </a:solidFill>
+          <a:ln>
+            <a:noFill/>
+          </a:ln>
+        </p:spPr>
+        <p:style>
+          <a:lnRef idx="1">
+            <a:schemeClr val="accent1"/>
+          </a:lnRef>
+          <a:fillRef idx="3">
+            <a:schemeClr val="accent1"/>
+          </a:fillRef>
+          <a:effectRef idx="2">
+            <a:schemeClr val="accent1"/>
+          </a:effectRef>
+          <a:fontRef idx="minor">
+            <a:schemeClr val="lt1"/>
+          </a:fontRef>
+        </p:style>
+        <p:txBody>
+          <a:bodyPr rtlCol="0" anchor="ctr"/>
+          <a:lstStyle/>
+          <a:p>
+            <a:pPr algn="ctr"/>
+          </a:p>
+        </p:txBody>
+      </p:sp>
+      <p:sp>
+        <p:nvSpPr>
+          <p:cNvPr id="5" name="TextBox 4"/>
+          <p:cNvSpPr txBox="1"/>
+          <p:nvPr/>
+        </p:nvSpPr>
+        <p:spPr>
+          <a:xfrm>
+            <a:off x="658368" y="6473952"/>
+            <a:ext cx="10881360" cy="219456"/>
+          </a:xfrm>
+          <a:prstGeom prst="rect">
+            <a:avLst/>
+          </a:prstGeom>
+          <a:noFill/>
+        </p:spPr>
+        <p:txBody>
+          <a:bodyPr wrap="none">
+            <a:spAutoFit/>
+          </a:bodyPr>
+          <a:lstStyle/>
+          <a:p>
+            <a:pPr algn="l">
+              <a:defRPr sz="800">
+                <a:solidFill>
+                  <a:srgbClr val="CBD5E1"/>
+                </a:solidFill>
+                <a:latin typeface="Aptos"/>
+              </a:defRPr>
+            </a:pPr>
+            <a:r>
+              <a:t>MBOASHIELD · SOVEREIGN DIGITAL TRUST INFRASTRUCTURE                                      04</a:t>
             </a:r>
           </a:p>
         </p:txBody>
@@ -3441,6 +3971,14 @@
 <file path=ppt/slides/slide5.xml><?xml version="1.0" encoding="utf-8"?>
 <p:sld xmlns:a="http://schemas.openxmlformats.org/drawingml/2006/main" xmlns:p="http://schemas.openxmlformats.org/presentationml/2006/main" xmlns:r="http://schemas.openxmlformats.org/officeDocument/2006/relationships">
   <p:cSld>
+    <p:bg>
+      <p:bgPr>
+        <a:solidFill>
+          <a:srgbClr val="071F1A"/>
+        </a:solidFill>
+        <a:effectLst/>
+      </p:bgPr>
+    </p:bg>
     <p:spTree>
       <p:nvGrpSpPr>
         <p:cNvPr id="1" name=""/>
@@ -3464,7 +4002,13 @@
           <a:lstStyle/>
           <a:p>
             <a:r>
-              <a:t>Platform depth (v1.9.0)</a:t>
+              <a:rPr sz="3000" b="1">
+                <a:solidFill>
+                  <a:srgbClr val="F8FAFC"/>
+                </a:solidFill>
+                <a:latin typeface="Aptos Display"/>
+              </a:rPr>
+              <a:t>National platform depth (v2.8.0)</a:t>
             </a:r>
           </a:p>
         </p:txBody>
@@ -3481,38 +4025,149 @@
         </p:nvSpPr>
         <p:spPr/>
         <p:txBody>
-          <a:bodyPr/>
+          <a:bodyPr lIns="109728"/>
           <a:lstStyle/>
           <a:p>
             <a:pPr>
-              <a:defRPr sz="2000"/>
+              <a:spcAft>
+                <a:spcPts val="1300"/>
+              </a:spcAft>
+              <a:defRPr sz="2100">
+                <a:solidFill>
+                  <a:srgbClr val="F8FAFC"/>
+                </a:solidFill>
+                <a:latin typeface="Aptos"/>
+              </a:defRPr>
             </a:pPr>
             <a:r>
-              <a:t>National incident workflow with human gates (no auto-public advisory)</a:t>
+              <a:t>TrustAssessment: one explainable object across text, identity, audio, image and intelligence</a:t>
             </a:r>
           </a:p>
           <a:p>
             <a:pPr>
-              <a:defRPr sz="2000"/>
+              <a:spcAft>
+                <a:spcPts val="1300"/>
+              </a:spcAft>
+              <a:defRPr sz="2100">
+                <a:solidFill>
+                  <a:srgbClr val="F8FAFC"/>
+                </a:solidFill>
+                <a:latin typeface="Aptos"/>
+              </a:defRPr>
             </a:pPr>
             <a:r>
-              <a:t>NTOC, intel, investigation, evidence vault, signed government announcements</a:t>
+              <a:t>Human-review incident workflow, NTOC, evidence and signed official communications</a:t>
             </a:r>
           </a:p>
           <a:p>
             <a:pPr>
-              <a:defRPr sz="2000"/>
+              <a:spcAft>
+                <a:spcPts val="1300"/>
+              </a:spcAft>
+              <a:defRPr sz="2100">
+                <a:solidFill>
+                  <a:srgbClr val="F8FAFC"/>
+                </a:solidFill>
+                <a:latin typeface="Aptos"/>
+              </a:defRPr>
             </a:pPr>
             <a:r>
-              <a:t>AI platform: model registry, golden EN/FR evaluation, certainty: none</a:t>
+              <a:t>Institution trust network plus webhooks, STIX, CAP, TAXII 2.1 and SCIM 2.0</a:t>
             </a:r>
           </a:p>
           <a:p>
             <a:pPr>
-              <a:defRPr sz="2000"/>
+              <a:spcAft>
+                <a:spcPts val="1300"/>
+              </a:spcAft>
+              <a:defRPr sz="2100">
+                <a:solidFill>
+                  <a:srgbClr val="F8FAFC"/>
+                </a:solidFill>
+                <a:latin typeface="Aptos"/>
+              </a:defRPr>
             </a:pPr>
             <a:r>
-              <a:t>Governance: consent, risk register, model and dataset cards</a:t>
+              <a:t>Governance, country packs, sector modules, HA/DR and load-test patterns</a:t>
+            </a:r>
+          </a:p>
+        </p:txBody>
+      </p:sp>
+      <p:sp>
+        <p:nvSpPr>
+          <p:cNvPr id="4" name="Rectangle 3"/>
+          <p:cNvSpPr/>
+          <p:nvPr/>
+        </p:nvSpPr>
+        <p:spPr>
+          <a:xfrm>
+            <a:off x="0" y="0"/>
+            <a:ext cx="146304" cy="6858000"/>
+          </a:xfrm>
+          <a:prstGeom prst="rect">
+            <a:avLst/>
+          </a:prstGeom>
+          <a:solidFill>
+            <a:srgbClr val="22C55E"/>
+          </a:solidFill>
+          <a:ln>
+            <a:noFill/>
+          </a:ln>
+        </p:spPr>
+        <p:style>
+          <a:lnRef idx="1">
+            <a:schemeClr val="accent1"/>
+          </a:lnRef>
+          <a:fillRef idx="3">
+            <a:schemeClr val="accent1"/>
+          </a:fillRef>
+          <a:effectRef idx="2">
+            <a:schemeClr val="accent1"/>
+          </a:effectRef>
+          <a:fontRef idx="minor">
+            <a:schemeClr val="lt1"/>
+          </a:fontRef>
+        </p:style>
+        <p:txBody>
+          <a:bodyPr rtlCol="0" anchor="ctr"/>
+          <a:lstStyle/>
+          <a:p>
+            <a:pPr algn="ctr"/>
+          </a:p>
+        </p:txBody>
+      </p:sp>
+      <p:sp>
+        <p:nvSpPr>
+          <p:cNvPr id="5" name="TextBox 4"/>
+          <p:cNvSpPr txBox="1"/>
+          <p:nvPr/>
+        </p:nvSpPr>
+        <p:spPr>
+          <a:xfrm>
+            <a:off x="658368" y="6473952"/>
+            <a:ext cx="10881360" cy="219456"/>
+          </a:xfrm>
+          <a:prstGeom prst="rect">
+            <a:avLst/>
+          </a:prstGeom>
+          <a:noFill/>
+        </p:spPr>
+        <p:txBody>
+          <a:bodyPr wrap="none">
+            <a:spAutoFit/>
+          </a:bodyPr>
+          <a:lstStyle/>
+          <a:p>
+            <a:pPr algn="l">
+              <a:defRPr sz="800">
+                <a:solidFill>
+                  <a:srgbClr val="CBD5E1"/>
+                </a:solidFill>
+                <a:latin typeface="Aptos"/>
+              </a:defRPr>
+            </a:pPr>
+            <a:r>
+              <a:t>MBOASHIELD · SOVEREIGN DIGITAL TRUST INFRASTRUCTURE                                      05</a:t>
             </a:r>
           </a:p>
         </p:txBody>
@@ -3528,6 +4183,14 @@
 <file path=ppt/slides/slide6.xml><?xml version="1.0" encoding="utf-8"?>
 <p:sld xmlns:a="http://schemas.openxmlformats.org/drawingml/2006/main" xmlns:p="http://schemas.openxmlformats.org/presentationml/2006/main" xmlns:r="http://schemas.openxmlformats.org/officeDocument/2006/relationships">
   <p:cSld>
+    <p:bg>
+      <p:bgPr>
+        <a:solidFill>
+          <a:srgbClr val="071F1A"/>
+        </a:solidFill>
+        <a:effectLst/>
+      </p:bgPr>
+    </p:bg>
     <p:spTree>
       <p:nvGrpSpPr>
         <p:cNvPr id="1" name=""/>
@@ -3551,6 +4214,12 @@
           <a:lstStyle/>
           <a:p>
             <a:r>
+              <a:rPr sz="3000" b="1">
+                <a:solidFill>
+                  <a:srgbClr val="F8FAFC"/>
+                </a:solidFill>
+                <a:latin typeface="Aptos Display"/>
+              </a:rPr>
               <a:t>Innovation and AI (honest)</a:t>
             </a:r>
           </a:p>
@@ -3568,11 +4237,19 @@
         </p:nvSpPr>
         <p:spPr/>
         <p:txBody>
-          <a:bodyPr/>
+          <a:bodyPr lIns="109728"/>
           <a:lstStyle/>
           <a:p>
             <a:pPr>
-              <a:defRPr sz="2000"/>
+              <a:spcAft>
+                <a:spcPts val="1300"/>
+              </a:spcAft>
+              <a:defRPr sz="2100">
+                <a:solidFill>
+                  <a:srgbClr val="F8FAFC"/>
+                </a:solidFill>
+                <a:latin typeface="Aptos"/>
+              </a:defRPr>
             </a:pPr>
             <a:r>
               <a:t>Text, audio, image, identity, civic modules - multimodal trust engine</a:t>
@@ -3580,7 +4257,15 @@
           </a:p>
           <a:p>
             <a:pPr>
-              <a:defRPr sz="2000"/>
+              <a:spcAft>
+                <a:spcPts val="1300"/>
+              </a:spcAft>
+              <a:defRPr sz="2100">
+                <a:solidFill>
+                  <a:srgbClr val="F8FAFC"/>
+                </a:solidFill>
+                <a:latin typeface="Aptos"/>
+              </a:defRPr>
             </a:pPr>
             <a:r>
               <a:t>17-institution registry for local impersonation detection</a:t>
@@ -3588,7 +4273,15 @@
           </a:p>
           <a:p>
             <a:pPr>
-              <a:defRPr sz="2000"/>
+              <a:spcAft>
+                <a:spcPts val="1300"/>
+              </a:spcAft>
+              <a:defRPr sz="2100">
+                <a:solidFill>
+                  <a:srgbClr val="F8FAFC"/>
+                </a:solidFill>
+                <a:latin typeface="Aptos"/>
+              </a:defRPr>
             </a:pPr>
             <a:r>
               <a:t>Heuristic and registry today; ONNX path with checksums for production</a:t>
@@ -3596,10 +4289,97 @@
           </a:p>
           <a:p>
             <a:pPr>
-              <a:defRPr sz="2000"/>
+              <a:spcAft>
+                <a:spcPts val="1300"/>
+              </a:spcAft>
+              <a:defRPr sz="2100">
+                <a:solidFill>
+                  <a:srgbClr val="F8FAFC"/>
+                </a:solidFill>
+                <a:latin typeface="Aptos"/>
+              </a:defRPr>
             </a:pPr>
             <a:r>
               <a:t>Differentiator: Cameroon WhatsApp context, institutions, civic mission</a:t>
+            </a:r>
+          </a:p>
+        </p:txBody>
+      </p:sp>
+      <p:sp>
+        <p:nvSpPr>
+          <p:cNvPr id="4" name="Rectangle 3"/>
+          <p:cNvSpPr/>
+          <p:nvPr/>
+        </p:nvSpPr>
+        <p:spPr>
+          <a:xfrm>
+            <a:off x="0" y="0"/>
+            <a:ext cx="146304" cy="6858000"/>
+          </a:xfrm>
+          <a:prstGeom prst="rect">
+            <a:avLst/>
+          </a:prstGeom>
+          <a:solidFill>
+            <a:srgbClr val="22C55E"/>
+          </a:solidFill>
+          <a:ln>
+            <a:noFill/>
+          </a:ln>
+        </p:spPr>
+        <p:style>
+          <a:lnRef idx="1">
+            <a:schemeClr val="accent1"/>
+          </a:lnRef>
+          <a:fillRef idx="3">
+            <a:schemeClr val="accent1"/>
+          </a:fillRef>
+          <a:effectRef idx="2">
+            <a:schemeClr val="accent1"/>
+          </a:effectRef>
+          <a:fontRef idx="minor">
+            <a:schemeClr val="lt1"/>
+          </a:fontRef>
+        </p:style>
+        <p:txBody>
+          <a:bodyPr rtlCol="0" anchor="ctr"/>
+          <a:lstStyle/>
+          <a:p>
+            <a:pPr algn="ctr"/>
+          </a:p>
+        </p:txBody>
+      </p:sp>
+      <p:sp>
+        <p:nvSpPr>
+          <p:cNvPr id="5" name="TextBox 4"/>
+          <p:cNvSpPr txBox="1"/>
+          <p:nvPr/>
+        </p:nvSpPr>
+        <p:spPr>
+          <a:xfrm>
+            <a:off x="658368" y="6473952"/>
+            <a:ext cx="10881360" cy="219456"/>
+          </a:xfrm>
+          <a:prstGeom prst="rect">
+            <a:avLst/>
+          </a:prstGeom>
+          <a:noFill/>
+        </p:spPr>
+        <p:txBody>
+          <a:bodyPr wrap="none">
+            <a:spAutoFit/>
+          </a:bodyPr>
+          <a:lstStyle/>
+          <a:p>
+            <a:pPr algn="l">
+              <a:defRPr sz="800">
+                <a:solidFill>
+                  <a:srgbClr val="CBD5E1"/>
+                </a:solidFill>
+                <a:latin typeface="Aptos"/>
+              </a:defRPr>
+            </a:pPr>
+            <a:r>
+              <a:t>MBOASHIELD · SOVEREIGN DIGITAL TRUST INFRASTRUCTURE                                      06</a:t>
             </a:r>
           </a:p>
         </p:txBody>
@@ -3615,6 +4395,14 @@
 <file path=ppt/slides/slide7.xml><?xml version="1.0" encoding="utf-8"?>
 <p:sld xmlns:a="http://schemas.openxmlformats.org/drawingml/2006/main" xmlns:p="http://schemas.openxmlformats.org/presentationml/2006/main" xmlns:r="http://schemas.openxmlformats.org/officeDocument/2006/relationships">
   <p:cSld>
+    <p:bg>
+      <p:bgPr>
+        <a:solidFill>
+          <a:srgbClr val="071F1A"/>
+        </a:solidFill>
+        <a:effectLst/>
+      </p:bgPr>
+    </p:bg>
     <p:spTree>
       <p:nvGrpSpPr>
         <p:cNvPr id="1" name=""/>
@@ -3638,6 +4426,12 @@
           <a:lstStyle/>
           <a:p>
             <a:r>
+              <a:rPr sz="3000" b="1">
+                <a:solidFill>
+                  <a:srgbClr val="F8FAFC"/>
+                </a:solidFill>
+                <a:latin typeface="Aptos Display"/>
+              </a:rPr>
               <a:t>Impact and digital patriotism</a:t>
             </a:r>
           </a:p>
@@ -3655,11 +4449,19 @@
         </p:nvSpPr>
         <p:spPr/>
         <p:txBody>
-          <a:bodyPr/>
+          <a:bodyPr lIns="109728"/>
           <a:lstStyle/>
           <a:p>
             <a:pPr>
-              <a:defRPr sz="2000"/>
+              <a:spcAft>
+                <a:spcPts val="1300"/>
+              </a:spcAft>
+              <a:defRPr sz="2100">
+                <a:solidFill>
+                  <a:srgbClr val="F8FAFC"/>
+                </a:solidFill>
+                <a:latin typeface="Aptos"/>
+              </a:defRPr>
             </a:pPr>
             <a:r>
               <a:t>Citizens: free checks and education</a:t>
@@ -3667,7 +4469,15 @@
           </a:p>
           <a:p>
             <a:pPr>
-              <a:defRPr sz="2000"/>
+              <a:spcAft>
+                <a:spcPts val="1300"/>
+              </a:spcAft>
+              <a:defRPr sz="2100">
+                <a:solidFill>
+                  <a:srgbClr val="F8FAFC"/>
+                </a:solidFill>
+                <a:latin typeface="Aptos"/>
+              </a:defRPr>
             </a:pPr>
             <a:r>
               <a:t>Schools and youth: Mboa Ambassadors</a:t>
@@ -3675,7 +4485,15 @@
           </a:p>
           <a:p>
             <a:pPr>
-              <a:defRPr sz="2000"/>
+              <a:spcAft>
+                <a:spcPts val="1300"/>
+              </a:spcAft>
+              <a:defRPr sz="2100">
+                <a:solidFill>
+                  <a:srgbClr val="F8FAFC"/>
+                </a:solidFill>
+                <a:latin typeface="Aptos"/>
+              </a:defRPr>
             </a:pPr>
             <a:r>
               <a:t>Media, banks, telcos: B2B API</a:t>
@@ -3683,10 +4501,97 @@
           </a:p>
           <a:p>
             <a:pPr>
-              <a:defRPr sz="2000"/>
+              <a:spcAft>
+                <a:spcPts val="1300"/>
+              </a:spcAft>
+              <a:defRPr sz="2100">
+                <a:solidFill>
+                  <a:srgbClr val="F8FAFC"/>
+                </a:solidFill>
+                <a:latin typeface="Aptos"/>
+              </a:defRPr>
             </a:pPr>
             <a:r>
               <a:t>Government: registry, verified comms, national analytics</a:t>
+            </a:r>
+          </a:p>
+        </p:txBody>
+      </p:sp>
+      <p:sp>
+        <p:nvSpPr>
+          <p:cNvPr id="4" name="Rectangle 3"/>
+          <p:cNvSpPr/>
+          <p:nvPr/>
+        </p:nvSpPr>
+        <p:spPr>
+          <a:xfrm>
+            <a:off x="0" y="0"/>
+            <a:ext cx="146304" cy="6858000"/>
+          </a:xfrm>
+          <a:prstGeom prst="rect">
+            <a:avLst/>
+          </a:prstGeom>
+          <a:solidFill>
+            <a:srgbClr val="22C55E"/>
+          </a:solidFill>
+          <a:ln>
+            <a:noFill/>
+          </a:ln>
+        </p:spPr>
+        <p:style>
+          <a:lnRef idx="1">
+            <a:schemeClr val="accent1"/>
+          </a:lnRef>
+          <a:fillRef idx="3">
+            <a:schemeClr val="accent1"/>
+          </a:fillRef>
+          <a:effectRef idx="2">
+            <a:schemeClr val="accent1"/>
+          </a:effectRef>
+          <a:fontRef idx="minor">
+            <a:schemeClr val="lt1"/>
+          </a:fontRef>
+        </p:style>
+        <p:txBody>
+          <a:bodyPr rtlCol="0" anchor="ctr"/>
+          <a:lstStyle/>
+          <a:p>
+            <a:pPr algn="ctr"/>
+          </a:p>
+        </p:txBody>
+      </p:sp>
+      <p:sp>
+        <p:nvSpPr>
+          <p:cNvPr id="5" name="TextBox 4"/>
+          <p:cNvSpPr txBox="1"/>
+          <p:nvPr/>
+        </p:nvSpPr>
+        <p:spPr>
+          <a:xfrm>
+            <a:off x="658368" y="6473952"/>
+            <a:ext cx="10881360" cy="219456"/>
+          </a:xfrm>
+          <a:prstGeom prst="rect">
+            <a:avLst/>
+          </a:prstGeom>
+          <a:noFill/>
+        </p:spPr>
+        <p:txBody>
+          <a:bodyPr wrap="none">
+            <a:spAutoFit/>
+          </a:bodyPr>
+          <a:lstStyle/>
+          <a:p>
+            <a:pPr algn="l">
+              <a:defRPr sz="800">
+                <a:solidFill>
+                  <a:srgbClr val="CBD5E1"/>
+                </a:solidFill>
+                <a:latin typeface="Aptos"/>
+              </a:defRPr>
+            </a:pPr>
+            <a:r>
+              <a:t>MBOASHIELD · SOVEREIGN DIGITAL TRUST INFRASTRUCTURE                                      07</a:t>
             </a:r>
           </a:p>
         </p:txBody>
@@ -3702,6 +4607,14 @@
 <file path=ppt/slides/slide8.xml><?xml version="1.0" encoding="utf-8"?>
 <p:sld xmlns:a="http://schemas.openxmlformats.org/drawingml/2006/main" xmlns:p="http://schemas.openxmlformats.org/presentationml/2006/main" xmlns:r="http://schemas.openxmlformats.org/officeDocument/2006/relationships">
   <p:cSld>
+    <p:bg>
+      <p:bgPr>
+        <a:solidFill>
+          <a:srgbClr val="071F1A"/>
+        </a:solidFill>
+        <a:effectLst/>
+      </p:bgPr>
+    </p:bg>
     <p:spTree>
       <p:nvGrpSpPr>
         <p:cNvPr id="1" name=""/>
@@ -3725,6 +4638,12 @@
           <a:lstStyle/>
           <a:p>
             <a:r>
+              <a:rPr sz="3000" b="1">
+                <a:solidFill>
+                  <a:srgbClr val="F8FAFC"/>
+                </a:solidFill>
+                <a:latin typeface="Aptos Display"/>
+              </a:rPr>
               <a:t>Business model</a:t>
             </a:r>
           </a:p>
@@ -3742,11 +4661,19 @@
         </p:nvSpPr>
         <p:spPr/>
         <p:txBody>
-          <a:bodyPr/>
+          <a:bodyPr lIns="109728"/>
           <a:lstStyle/>
           <a:p>
             <a:pPr>
-              <a:defRPr sz="2000"/>
+              <a:spcAft>
+                <a:spcPts val="1300"/>
+              </a:spcAft>
+              <a:defRPr sz="2100">
+                <a:solidFill>
+                  <a:srgbClr val="F8FAFC"/>
+                </a:solidFill>
+                <a:latin typeface="Aptos"/>
+              </a:defRPr>
             </a:pPr>
             <a:r>
               <a:t>Citizen Check: free (mission and sponsors)</a:t>
@@ -3754,7 +4681,15 @@
           </a:p>
           <a:p>
             <a:pPr>
-              <a:defRPr sz="2000"/>
+              <a:spcAft>
+                <a:spcPts val="1300"/>
+              </a:spcAft>
+              <a:defRPr sz="2100">
+                <a:solidFill>
+                  <a:srgbClr val="F8FAFC"/>
+                </a:solidFill>
+                <a:latin typeface="Aptos"/>
+              </a:defRPr>
             </a:pPr>
             <a:r>
               <a:t>Pro: media/SMEs - 75k to 250k FCFA/month</a:t>
@@ -3762,7 +4697,15 @@
           </a:p>
           <a:p>
             <a:pPr>
-              <a:defRPr sz="2000"/>
+              <a:spcAft>
+                <a:spcPts val="1300"/>
+              </a:spcAft>
+              <a:defRPr sz="2100">
+                <a:solidFill>
+                  <a:srgbClr val="F8FAFC"/>
+                </a:solidFill>
+                <a:latin typeface="Aptos"/>
+              </a:defRPr>
             </a:pPr>
             <a:r>
               <a:t>Enterprise: banks/telcos - annual API</a:t>
@@ -3770,7 +4713,15 @@
           </a:p>
           <a:p>
             <a:pPr>
-              <a:defRPr sz="2000"/>
+              <a:spcAft>
+                <a:spcPts val="1300"/>
+              </a:spcAft>
+              <a:defRPr sz="2100">
+                <a:solidFill>
+                  <a:srgbClr val="F8FAFC"/>
+                </a:solidFill>
+                <a:latin typeface="Aptos"/>
+              </a:defRPr>
             </a:pPr>
             <a:r>
               <a:t>Ambassadors: schools - training packs</a:t>
@@ -3778,10 +4729,97 @@
           </a:p>
           <a:p>
             <a:pPr>
-              <a:defRPr sz="2000"/>
+              <a:spcAft>
+                <a:spcPts val="1300"/>
+              </a:spcAft>
+              <a:defRPr sz="2100">
+                <a:solidFill>
+                  <a:srgbClr val="F8FAFC"/>
+                </a:solidFill>
+                <a:latin typeface="Aptos"/>
+              </a:defRPr>
             </a:pPr>
             <a:r>
               <a:t>Year 1 target: pilots and 18-25M FCFA revenue path</a:t>
+            </a:r>
+          </a:p>
+        </p:txBody>
+      </p:sp>
+      <p:sp>
+        <p:nvSpPr>
+          <p:cNvPr id="4" name="Rectangle 3"/>
+          <p:cNvSpPr/>
+          <p:nvPr/>
+        </p:nvSpPr>
+        <p:spPr>
+          <a:xfrm>
+            <a:off x="0" y="0"/>
+            <a:ext cx="146304" cy="6858000"/>
+          </a:xfrm>
+          <a:prstGeom prst="rect">
+            <a:avLst/>
+          </a:prstGeom>
+          <a:solidFill>
+            <a:srgbClr val="22C55E"/>
+          </a:solidFill>
+          <a:ln>
+            <a:noFill/>
+          </a:ln>
+        </p:spPr>
+        <p:style>
+          <a:lnRef idx="1">
+            <a:schemeClr val="accent1"/>
+          </a:lnRef>
+          <a:fillRef idx="3">
+            <a:schemeClr val="accent1"/>
+          </a:fillRef>
+          <a:effectRef idx="2">
+            <a:schemeClr val="accent1"/>
+          </a:effectRef>
+          <a:fontRef idx="minor">
+            <a:schemeClr val="lt1"/>
+          </a:fontRef>
+        </p:style>
+        <p:txBody>
+          <a:bodyPr rtlCol="0" anchor="ctr"/>
+          <a:lstStyle/>
+          <a:p>
+            <a:pPr algn="ctr"/>
+          </a:p>
+        </p:txBody>
+      </p:sp>
+      <p:sp>
+        <p:nvSpPr>
+          <p:cNvPr id="5" name="TextBox 4"/>
+          <p:cNvSpPr txBox="1"/>
+          <p:nvPr/>
+        </p:nvSpPr>
+        <p:spPr>
+          <a:xfrm>
+            <a:off x="658368" y="6473952"/>
+            <a:ext cx="10881360" cy="219456"/>
+          </a:xfrm>
+          <a:prstGeom prst="rect">
+            <a:avLst/>
+          </a:prstGeom>
+          <a:noFill/>
+        </p:spPr>
+        <p:txBody>
+          <a:bodyPr wrap="none">
+            <a:spAutoFit/>
+          </a:bodyPr>
+          <a:lstStyle/>
+          <a:p>
+            <a:pPr algn="l">
+              <a:defRPr sz="800">
+                <a:solidFill>
+                  <a:srgbClr val="CBD5E1"/>
+                </a:solidFill>
+                <a:latin typeface="Aptos"/>
+              </a:defRPr>
+            </a:pPr>
+            <a:r>
+              <a:t>MBOASHIELD · SOVEREIGN DIGITAL TRUST INFRASTRUCTURE                                      08</a:t>
             </a:r>
           </a:p>
         </p:txBody>
@@ -3797,6 +4835,14 @@
 <file path=ppt/slides/slide9.xml><?xml version="1.0" encoding="utf-8"?>
 <p:sld xmlns:a="http://schemas.openxmlformats.org/drawingml/2006/main" xmlns:p="http://schemas.openxmlformats.org/presentationml/2006/main" xmlns:r="http://schemas.openxmlformats.org/officeDocument/2006/relationships">
   <p:cSld>
+    <p:bg>
+      <p:bgPr>
+        <a:solidFill>
+          <a:srgbClr val="071F1A"/>
+        </a:solidFill>
+        <a:effectLst/>
+      </p:bgPr>
+    </p:bg>
     <p:spTree>
       <p:nvGrpSpPr>
         <p:cNvPr id="1" name=""/>
@@ -3820,6 +4866,12 @@
           <a:lstStyle/>
           <a:p>
             <a:r>
+              <a:rPr sz="3000" b="1">
+                <a:solidFill>
+                  <a:srgbClr val="F8FAFC"/>
+                </a:solidFill>
+                <a:latin typeface="Aptos Display"/>
+              </a:rPr>
               <a:t>The ask</a:t>
             </a:r>
           </a:p>
@@ -3837,11 +4889,19 @@
         </p:nvSpPr>
         <p:spPr/>
         <p:txBody>
-          <a:bodyPr/>
+          <a:bodyPr lIns="109728"/>
           <a:lstStyle/>
           <a:p>
             <a:pPr>
-              <a:defRPr sz="2000"/>
+              <a:spcAft>
+                <a:spcPts val="1300"/>
+              </a:spcAft>
+              <a:defRPr sz="2100">
+                <a:solidFill>
+                  <a:srgbClr val="F8FAFC"/>
+                </a:solidFill>
+                <a:latin typeface="Aptos"/>
+              </a:defRPr>
             </a:pPr>
             <a:r>
               <a:t>Special Prize of the President of the Republic to:</a:t>
@@ -3849,7 +4909,15 @@
           </a:p>
           <a:p>
             <a:pPr>
-              <a:defRPr sz="2000"/>
+              <a:spcAft>
+                <a:spcPts val="1300"/>
+              </a:spcAft>
+              <a:defRPr sz="2100">
+                <a:solidFill>
+                  <a:srgbClr val="F8FAFC"/>
+                </a:solidFill>
+                <a:latin typeface="Aptos"/>
+              </a:defRPr>
             </a:pPr>
             <a:r>
               <a:t>1. Industrialise MboaShield nationally</a:t>
@@ -3857,7 +4925,15 @@
           </a:p>
           <a:p>
             <a:pPr>
-              <a:defRPr sz="2000"/>
+              <a:spcAft>
+                <a:spcPts val="1300"/>
+              </a:spcAft>
+              <a:defRPr sz="2100">
+                <a:solidFill>
+                  <a:srgbClr val="F8FAFC"/>
+                </a:solidFill>
+                <a:latin typeface="Aptos"/>
+              </a:defRPr>
             </a:pPr>
             <a:r>
               <a:t>2. Launch institutional identity registry v1 at scale</a:t>
@@ -3865,7 +4941,15 @@
           </a:p>
           <a:p>
             <a:pPr>
-              <a:defRPr sz="2000"/>
+              <a:spcAft>
+                <a:spcPts val="1300"/>
+              </a:spcAft>
+              <a:defRPr sz="2100">
+                <a:solidFill>
+                  <a:srgbClr val="F8FAFC"/>
+                </a:solidFill>
+                <a:latin typeface="Aptos"/>
+              </a:defRPr>
             </a:pPr>
             <a:r>
               <a:t>3. Train 50,000 Mboa Ambassadors in Year 1</a:t>
@@ -3873,7 +4957,15 @@
           </a:p>
           <a:p>
             <a:pPr>
-              <a:defRPr sz="2000"/>
+              <a:spcAft>
+                <a:spcPts val="1300"/>
+              </a:spcAft>
+              <a:defRPr sz="2100">
+                <a:solidFill>
+                  <a:srgbClr val="F8FAFC"/>
+                </a:solidFill>
+                <a:latin typeface="Aptos"/>
+              </a:defRPr>
             </a:pPr>
             <a:r>
               <a:t>MboaShield IS the 2026 theme - not adjacent to it.</a:t>
@@ -3881,10 +4973,97 @@
           </a:p>
           <a:p>
             <a:pPr>
-              <a:defRPr sz="2000"/>
+              <a:spcAft>
+                <a:spcPts val="1300"/>
+              </a:spcAft>
+              <a:defRPr sz="2100">
+                <a:solidFill>
+                  <a:srgbClr val="F8FAFC"/>
+                </a:solidFill>
+                <a:latin typeface="Aptos"/>
+              </a:defRPr>
             </a:pPr>
             <a:r>
               <a:t>tamahjustene45@gmail.com - github.com/TamahJustene/MboaShield</a:t>
+            </a:r>
+          </a:p>
+        </p:txBody>
+      </p:sp>
+      <p:sp>
+        <p:nvSpPr>
+          <p:cNvPr id="4" name="Rectangle 3"/>
+          <p:cNvSpPr/>
+          <p:nvPr/>
+        </p:nvSpPr>
+        <p:spPr>
+          <a:xfrm>
+            <a:off x="0" y="0"/>
+            <a:ext cx="146304" cy="6858000"/>
+          </a:xfrm>
+          <a:prstGeom prst="rect">
+            <a:avLst/>
+          </a:prstGeom>
+          <a:solidFill>
+            <a:srgbClr val="22C55E"/>
+          </a:solidFill>
+          <a:ln>
+            <a:noFill/>
+          </a:ln>
+        </p:spPr>
+        <p:style>
+          <a:lnRef idx="1">
+            <a:schemeClr val="accent1"/>
+          </a:lnRef>
+          <a:fillRef idx="3">
+            <a:schemeClr val="accent1"/>
+          </a:fillRef>
+          <a:effectRef idx="2">
+            <a:schemeClr val="accent1"/>
+          </a:effectRef>
+          <a:fontRef idx="minor">
+            <a:schemeClr val="lt1"/>
+          </a:fontRef>
+        </p:style>
+        <p:txBody>
+          <a:bodyPr rtlCol="0" anchor="ctr"/>
+          <a:lstStyle/>
+          <a:p>
+            <a:pPr algn="ctr"/>
+          </a:p>
+        </p:txBody>
+      </p:sp>
+      <p:sp>
+        <p:nvSpPr>
+          <p:cNvPr id="5" name="TextBox 4"/>
+          <p:cNvSpPr txBox="1"/>
+          <p:nvPr/>
+        </p:nvSpPr>
+        <p:spPr>
+          <a:xfrm>
+            <a:off x="658368" y="6473952"/>
+            <a:ext cx="10881360" cy="219456"/>
+          </a:xfrm>
+          <a:prstGeom prst="rect">
+            <a:avLst/>
+          </a:prstGeom>
+          <a:noFill/>
+        </p:spPr>
+        <p:txBody>
+          <a:bodyPr wrap="none">
+            <a:spAutoFit/>
+          </a:bodyPr>
+          <a:lstStyle/>
+          <a:p>
+            <a:pPr algn="l">
+              <a:defRPr sz="800">
+                <a:solidFill>
+                  <a:srgbClr val="CBD5E1"/>
+                </a:solidFill>
+                <a:latin typeface="Aptos"/>
+              </a:defRPr>
+            </a:pPr>
+            <a:r>
+              <a:t>MBOASHIELD · SOVEREIGN DIGITAL TRUST INFRASTRUCTURE                                      09</a:t>
             </a:r>
           </a:p>
         </p:txBody>

</xml_diff>